<commit_message>
Rehace visualmente las diapositivas de Temas 1 a 5
Reconstruye los decks de primer-contacto-aws, vpc-diseno, seguridad-red,
maquinas-virtuales, almacenamiento, bases-datos-gestionadas,
arquitectura-completa, alta-disponibilidad-escalado, dns-https-cdn,
monitorizacion-operacion, iam-aplicado y economia-nube con tarjetas,
tablas y diagramas nativos en vez de listados de texto, revisadas a
90dpi para descartar solapamientos.
</commit_message>
<xml_diff>
--- a/docs/tema5/diapositivas/economia-nube.pptx
+++ b/docs/tema5/diapositivas/economia-nube.pptx
@@ -8095,14 +8095,64 @@
       </p:sp>
       <p:sp>
         <p:nvSpPr>
-          <p:cNvPr id="5" name="Text 3"/>
+          <p:cNvPr id="5" name="Shape 3"/>
           <p:cNvSpPr/>
           <p:nvPr/>
         </p:nvSpPr>
         <p:spPr>
           <a:xfrm>
-            <a:off x="548640" y="1188720"/>
-            <a:ext cx="11091672" cy="4389120"/>
+            <a:off x="548640" y="1280160"/>
+            <a:ext cx="5431536" cy="1325880"/>
+          </a:xfrm>
+          <a:prstGeom prst="roundRect">
+            <a:avLst/>
+          </a:prstGeom>
+          <a:solidFill>
+            <a:srgbClr val="E8EAF6"/>
+          </a:solidFill>
+          <a:ln w="15875">
+            <a:solidFill>
+              <a:srgbClr val="3949AB"/>
+            </a:solidFill>
+            <a:prstDash val="solid"/>
+          </a:ln>
+        </p:spPr>
+      </p:sp>
+      <p:sp>
+        <p:nvSpPr>
+          <p:cNvPr id="6" name="Shape 4"/>
+          <p:cNvSpPr/>
+          <p:nvPr/>
+        </p:nvSpPr>
+        <p:spPr>
+          <a:xfrm>
+            <a:off x="731520" y="1650492"/>
+            <a:ext cx="566928" cy="566928"/>
+          </a:xfrm>
+          <a:prstGeom prst="ellipse">
+            <a:avLst/>
+          </a:prstGeom>
+          <a:solidFill>
+            <a:srgbClr val="3949AB"/>
+          </a:solidFill>
+          <a:ln w="12700">
+            <a:solidFill>
+              <a:srgbClr val="3949AB"/>
+            </a:solidFill>
+            <a:prstDash val="solid"/>
+          </a:ln>
+        </p:spPr>
+      </p:sp>
+      <p:sp>
+        <p:nvSpPr>
+          <p:cNvPr id="7" name="Text 5"/>
+          <p:cNvSpPr/>
+          <p:nvPr/>
+        </p:nvSpPr>
+        <p:spPr>
+          <a:xfrm>
+            <a:off x="731520" y="1650492"/>
+            <a:ext cx="566928" cy="566928"/>
           </a:xfrm>
           <a:prstGeom prst="rect">
             <a:avLst/>
@@ -8111,18 +8161,53 @@
           <a:ln/>
         </p:spPr>
         <p:txBody>
-          <a:bodyPr wrap="square" rtlCol="0" anchor="t"/>
+          <a:bodyPr wrap="square" rtlCol="0" anchor="ctr"/>
           <a:lstStyle/>
           <a:p>
-            <a:pPr marL="190500" indent="-190500">
-              <a:spcAft>
-                <a:spcPts val="1400"/>
-              </a:spcAft>
-              <a:buSzPct val="100000"/>
-              <a:buChar char="•"/>
+            <a:pPr algn="ctr" indent="0" marL="0">
+              <a:buNone/>
             </a:pPr>
             <a:r>
-              <a:rPr lang="en-US" sz="1600" dirty="0">
+              <a:rPr lang="en-US" sz="1700" b="1" dirty="0">
+                <a:solidFill>
+                  <a:srgbClr val="FFFFFF"/>
+                </a:solidFill>
+                <a:latin typeface="Arial" pitchFamily="34" charset="0"/>
+                <a:ea typeface="Arial" pitchFamily="34" charset="-122"/>
+                <a:cs typeface="Arial" pitchFamily="34" charset="-120"/>
+              </a:rPr>
+              <a:t>1</a:t>
+            </a:r>
+            <a:endParaRPr lang="en-US" sz="1700" dirty="0"/>
+          </a:p>
+        </p:txBody>
+      </p:sp>
+      <p:sp>
+        <p:nvSpPr>
+          <p:cNvPr id="8" name="Text 6"/>
+          <p:cNvSpPr/>
+          <p:nvPr/>
+        </p:nvSpPr>
+        <p:spPr>
+          <a:xfrm>
+            <a:off x="1417320" y="1280160"/>
+            <a:ext cx="4379976" cy="1325880"/>
+          </a:xfrm>
+          <a:prstGeom prst="rect">
+            <a:avLst/>
+          </a:prstGeom>
+          <a:noFill/>
+          <a:ln/>
+        </p:spPr>
+        <p:txBody>
+          <a:bodyPr wrap="square" rtlCol="0" anchor="ctr"/>
+          <a:lstStyle/>
+          <a:p>
+            <a:pPr indent="0" marL="0">
+              <a:buNone/>
+            </a:pPr>
+            <a:r>
+              <a:rPr lang="en-US" sz="1500" dirty="0">
                 <a:solidFill>
                   <a:srgbClr val="212121"/>
                 </a:solidFill>
@@ -8132,18 +8217,125 @@
               </a:rPr>
               <a:t>Cada servicio se factura con su propia unidad: cómputo por segundo, almacenamiento por GB-mes, transferencia de salida por GB, peticiones por operación.</a:t>
             </a:r>
-            <a:endParaRPr lang="en-US" sz="1600" dirty="0"/>
+            <a:endParaRPr lang="en-US" sz="1500" dirty="0"/>
           </a:p>
+        </p:txBody>
+      </p:sp>
+      <p:sp>
+        <p:nvSpPr>
+          <p:cNvPr id="9" name="Shape 7"/>
+          <p:cNvSpPr/>
+          <p:nvPr/>
+        </p:nvSpPr>
+        <p:spPr>
+          <a:xfrm>
+            <a:off x="6208776" y="1280160"/>
+            <a:ext cx="5431536" cy="1325880"/>
+          </a:xfrm>
+          <a:prstGeom prst="roundRect">
+            <a:avLst/>
+          </a:prstGeom>
+          <a:solidFill>
+            <a:srgbClr val="E8EAF6"/>
+          </a:solidFill>
+          <a:ln w="15875">
+            <a:solidFill>
+              <a:srgbClr val="3949AB"/>
+            </a:solidFill>
+            <a:prstDash val="solid"/>
+          </a:ln>
+        </p:spPr>
+      </p:sp>
+      <p:sp>
+        <p:nvSpPr>
+          <p:cNvPr id="10" name="Shape 8"/>
+          <p:cNvSpPr/>
+          <p:nvPr/>
+        </p:nvSpPr>
+        <p:spPr>
+          <a:xfrm>
+            <a:off x="6391656" y="1650492"/>
+            <a:ext cx="566928" cy="566928"/>
+          </a:xfrm>
+          <a:prstGeom prst="ellipse">
+            <a:avLst/>
+          </a:prstGeom>
+          <a:solidFill>
+            <a:srgbClr val="3949AB"/>
+          </a:solidFill>
+          <a:ln w="12700">
+            <a:solidFill>
+              <a:srgbClr val="3949AB"/>
+            </a:solidFill>
+            <a:prstDash val="solid"/>
+          </a:ln>
+        </p:spPr>
+      </p:sp>
+      <p:sp>
+        <p:nvSpPr>
+          <p:cNvPr id="11" name="Text 9"/>
+          <p:cNvSpPr/>
+          <p:nvPr/>
+        </p:nvSpPr>
+        <p:spPr>
+          <a:xfrm>
+            <a:off x="6391656" y="1650492"/>
+            <a:ext cx="566928" cy="566928"/>
+          </a:xfrm>
+          <a:prstGeom prst="rect">
+            <a:avLst/>
+          </a:prstGeom>
+          <a:noFill/>
+          <a:ln/>
+        </p:spPr>
+        <p:txBody>
+          <a:bodyPr wrap="square" rtlCol="0" anchor="ctr"/>
+          <a:lstStyle/>
           <a:p>
-            <a:pPr marL="190500" indent="-190500">
-              <a:spcAft>
-                <a:spcPts val="1400"/>
-              </a:spcAft>
-              <a:buSzPct val="100000"/>
-              <a:buChar char="•"/>
+            <a:pPr algn="ctr" indent="0" marL="0">
+              <a:buNone/>
             </a:pPr>
             <a:r>
-              <a:rPr lang="en-US" sz="1600" dirty="0">
+              <a:rPr lang="en-US" sz="1700" b="1" dirty="0">
+                <a:solidFill>
+                  <a:srgbClr val="FFFFFF"/>
+                </a:solidFill>
+                <a:latin typeface="Arial" pitchFamily="34" charset="0"/>
+                <a:ea typeface="Arial" pitchFamily="34" charset="-122"/>
+                <a:cs typeface="Arial" pitchFamily="34" charset="-120"/>
+              </a:rPr>
+              <a:t>2</a:t>
+            </a:r>
+            <a:endParaRPr lang="en-US" sz="1700" dirty="0"/>
+          </a:p>
+        </p:txBody>
+      </p:sp>
+      <p:sp>
+        <p:nvSpPr>
+          <p:cNvPr id="12" name="Text 10"/>
+          <p:cNvSpPr/>
+          <p:nvPr/>
+        </p:nvSpPr>
+        <p:spPr>
+          <a:xfrm>
+            <a:off x="7077456" y="1280160"/>
+            <a:ext cx="4379976" cy="1325880"/>
+          </a:xfrm>
+          <a:prstGeom prst="rect">
+            <a:avLst/>
+          </a:prstGeom>
+          <a:noFill/>
+          <a:ln/>
+        </p:spPr>
+        <p:txBody>
+          <a:bodyPr wrap="square" rtlCol="0" anchor="ctr"/>
+          <a:lstStyle/>
+          <a:p>
+            <a:pPr indent="0" marL="0">
+              <a:buNone/>
+            </a:pPr>
+            <a:r>
+              <a:rPr lang="en-US" sz="1500" dirty="0">
                 <a:solidFill>
                   <a:srgbClr val="212121"/>
                 </a:solidFill>
@@ -8153,18 +8345,125 @@
               </a:rPr>
               <a:t>La capa gratuita tiene tres formas distintas y no es lo mismo que el crédito del Learner Lab.</a:t>
             </a:r>
-            <a:endParaRPr lang="en-US" sz="1600" dirty="0"/>
+            <a:endParaRPr lang="en-US" sz="1500" dirty="0"/>
           </a:p>
+        </p:txBody>
+      </p:sp>
+      <p:sp>
+        <p:nvSpPr>
+          <p:cNvPr id="13" name="Shape 11"/>
+          <p:cNvSpPr/>
+          <p:nvPr/>
+        </p:nvSpPr>
+        <p:spPr>
+          <a:xfrm>
+            <a:off x="548640" y="2834640"/>
+            <a:ext cx="5431536" cy="1325880"/>
+          </a:xfrm>
+          <a:prstGeom prst="roundRect">
+            <a:avLst/>
+          </a:prstGeom>
+          <a:solidFill>
+            <a:srgbClr val="E8EAF6"/>
+          </a:solidFill>
+          <a:ln w="15875">
+            <a:solidFill>
+              <a:srgbClr val="3949AB"/>
+            </a:solidFill>
+            <a:prstDash val="solid"/>
+          </a:ln>
+        </p:spPr>
+      </p:sp>
+      <p:sp>
+        <p:nvSpPr>
+          <p:cNvPr id="14" name="Shape 12"/>
+          <p:cNvSpPr/>
+          <p:nvPr/>
+        </p:nvSpPr>
+        <p:spPr>
+          <a:xfrm>
+            <a:off x="731520" y="3204972"/>
+            <a:ext cx="566928" cy="566928"/>
+          </a:xfrm>
+          <a:prstGeom prst="ellipse">
+            <a:avLst/>
+          </a:prstGeom>
+          <a:solidFill>
+            <a:srgbClr val="3949AB"/>
+          </a:solidFill>
+          <a:ln w="12700">
+            <a:solidFill>
+              <a:srgbClr val="3949AB"/>
+            </a:solidFill>
+            <a:prstDash val="solid"/>
+          </a:ln>
+        </p:spPr>
+      </p:sp>
+      <p:sp>
+        <p:nvSpPr>
+          <p:cNvPr id="15" name="Text 13"/>
+          <p:cNvSpPr/>
+          <p:nvPr/>
+        </p:nvSpPr>
+        <p:spPr>
+          <a:xfrm>
+            <a:off x="731520" y="3204972"/>
+            <a:ext cx="566928" cy="566928"/>
+          </a:xfrm>
+          <a:prstGeom prst="rect">
+            <a:avLst/>
+          </a:prstGeom>
+          <a:noFill/>
+          <a:ln/>
+        </p:spPr>
+        <p:txBody>
+          <a:bodyPr wrap="square" rtlCol="0" anchor="ctr"/>
+          <a:lstStyle/>
           <a:p>
-            <a:pPr marL="190500" indent="-190500">
-              <a:spcAft>
-                <a:spcPts val="1400"/>
-              </a:spcAft>
-              <a:buSzPct val="100000"/>
-              <a:buChar char="•"/>
+            <a:pPr algn="ctr" indent="0" marL="0">
+              <a:buNone/>
             </a:pPr>
             <a:r>
-              <a:rPr lang="en-US" sz="1600" dirty="0">
+              <a:rPr lang="en-US" sz="1700" b="1" dirty="0">
+                <a:solidFill>
+                  <a:srgbClr val="FFFFFF"/>
+                </a:solidFill>
+                <a:latin typeface="Arial" pitchFamily="34" charset="0"/>
+                <a:ea typeface="Arial" pitchFamily="34" charset="-122"/>
+                <a:cs typeface="Arial" pitchFamily="34" charset="-120"/>
+              </a:rPr>
+              <a:t>3</a:t>
+            </a:r>
+            <a:endParaRPr lang="en-US" sz="1700" dirty="0"/>
+          </a:p>
+        </p:txBody>
+      </p:sp>
+      <p:sp>
+        <p:nvSpPr>
+          <p:cNvPr id="16" name="Text 14"/>
+          <p:cNvSpPr/>
+          <p:nvPr/>
+        </p:nvSpPr>
+        <p:spPr>
+          <a:xfrm>
+            <a:off x="1417320" y="2834640"/>
+            <a:ext cx="4379976" cy="1325880"/>
+          </a:xfrm>
+          <a:prstGeom prst="rect">
+            <a:avLst/>
+          </a:prstGeom>
+          <a:noFill/>
+          <a:ln/>
+        </p:spPr>
+        <p:txBody>
+          <a:bodyPr wrap="square" rtlCol="0" anchor="ctr"/>
+          <a:lstStyle/>
+          <a:p>
+            <a:pPr indent="0" marL="0">
+              <a:buNone/>
+            </a:pPr>
+            <a:r>
+              <a:rPr lang="en-US" sz="1500" dirty="0">
                 <a:solidFill>
                   <a:srgbClr val="212121"/>
                 </a:solidFill>
@@ -8174,18 +8473,125 @@
               </a:rPr>
               <a:t>Los modelos de compra van de bajo demanda (flexible, caro) a reservas y planes de ahorro (compromiso, descuento) hasta Spot (muy barato, interrumpible).</a:t>
             </a:r>
-            <a:endParaRPr lang="en-US" sz="1600" dirty="0"/>
+            <a:endParaRPr lang="en-US" sz="1500" dirty="0"/>
           </a:p>
+        </p:txBody>
+      </p:sp>
+      <p:sp>
+        <p:nvSpPr>
+          <p:cNvPr id="17" name="Shape 15"/>
+          <p:cNvSpPr/>
+          <p:nvPr/>
+        </p:nvSpPr>
+        <p:spPr>
+          <a:xfrm>
+            <a:off x="6208776" y="2834640"/>
+            <a:ext cx="5431536" cy="1325880"/>
+          </a:xfrm>
+          <a:prstGeom prst="roundRect">
+            <a:avLst/>
+          </a:prstGeom>
+          <a:solidFill>
+            <a:srgbClr val="E8EAF6"/>
+          </a:solidFill>
+          <a:ln w="15875">
+            <a:solidFill>
+              <a:srgbClr val="3949AB"/>
+            </a:solidFill>
+            <a:prstDash val="solid"/>
+          </a:ln>
+        </p:spPr>
+      </p:sp>
+      <p:sp>
+        <p:nvSpPr>
+          <p:cNvPr id="18" name="Shape 16"/>
+          <p:cNvSpPr/>
+          <p:nvPr/>
+        </p:nvSpPr>
+        <p:spPr>
+          <a:xfrm>
+            <a:off x="6391656" y="3204972"/>
+            <a:ext cx="566928" cy="566928"/>
+          </a:xfrm>
+          <a:prstGeom prst="ellipse">
+            <a:avLst/>
+          </a:prstGeom>
+          <a:solidFill>
+            <a:srgbClr val="3949AB"/>
+          </a:solidFill>
+          <a:ln w="12700">
+            <a:solidFill>
+              <a:srgbClr val="3949AB"/>
+            </a:solidFill>
+            <a:prstDash val="solid"/>
+          </a:ln>
+        </p:spPr>
+      </p:sp>
+      <p:sp>
+        <p:nvSpPr>
+          <p:cNvPr id="19" name="Text 17"/>
+          <p:cNvSpPr/>
+          <p:nvPr/>
+        </p:nvSpPr>
+        <p:spPr>
+          <a:xfrm>
+            <a:off x="6391656" y="3204972"/>
+            <a:ext cx="566928" cy="566928"/>
+          </a:xfrm>
+          <a:prstGeom prst="rect">
+            <a:avLst/>
+          </a:prstGeom>
+          <a:noFill/>
+          <a:ln/>
+        </p:spPr>
+        <p:txBody>
+          <a:bodyPr wrap="square" rtlCol="0" anchor="ctr"/>
+          <a:lstStyle/>
           <a:p>
-            <a:pPr marL="190500" indent="-190500">
-              <a:spcAft>
-                <a:spcPts val="1400"/>
-              </a:spcAft>
-              <a:buSzPct val="100000"/>
-              <a:buChar char="•"/>
+            <a:pPr algn="ctr" indent="0" marL="0">
+              <a:buNone/>
             </a:pPr>
             <a:r>
-              <a:rPr lang="en-US" sz="1600" dirty="0">
+              <a:rPr lang="en-US" sz="1700" b="1" dirty="0">
+                <a:solidFill>
+                  <a:srgbClr val="FFFFFF"/>
+                </a:solidFill>
+                <a:latin typeface="Arial" pitchFamily="34" charset="0"/>
+                <a:ea typeface="Arial" pitchFamily="34" charset="-122"/>
+                <a:cs typeface="Arial" pitchFamily="34" charset="-120"/>
+              </a:rPr>
+              <a:t>4</a:t>
+            </a:r>
+            <a:endParaRPr lang="en-US" sz="1700" dirty="0"/>
+          </a:p>
+        </p:txBody>
+      </p:sp>
+      <p:sp>
+        <p:nvSpPr>
+          <p:cNvPr id="20" name="Text 18"/>
+          <p:cNvSpPr/>
+          <p:nvPr/>
+        </p:nvSpPr>
+        <p:spPr>
+          <a:xfrm>
+            <a:off x="7077456" y="2834640"/>
+            <a:ext cx="4379976" cy="1325880"/>
+          </a:xfrm>
+          <a:prstGeom prst="rect">
+            <a:avLst/>
+          </a:prstGeom>
+          <a:noFill/>
+          <a:ln/>
+        </p:spPr>
+        <p:txBody>
+          <a:bodyPr wrap="square" rtlCol="0" anchor="ctr"/>
+          <a:lstStyle/>
+          <a:p>
+            <a:pPr indent="0" marL="0">
+              <a:buNone/>
+            </a:pPr>
+            <a:r>
+              <a:rPr lang="en-US" sz="1500" dirty="0">
                 <a:solidFill>
                   <a:srgbClr val="212121"/>
                 </a:solidFill>
@@ -8195,18 +8601,125 @@
               </a:rPr>
               <a:t>Las 6 R de la migración van de mover tal cual a rediseñar por completo — la mejor no es siempre la más ambiciosa.</a:t>
             </a:r>
-            <a:endParaRPr lang="en-US" sz="1600" dirty="0"/>
+            <a:endParaRPr lang="en-US" sz="1500" dirty="0"/>
           </a:p>
+        </p:txBody>
+      </p:sp>
+      <p:sp>
+        <p:nvSpPr>
+          <p:cNvPr id="21" name="Shape 19"/>
+          <p:cNvSpPr/>
+          <p:nvPr/>
+        </p:nvSpPr>
+        <p:spPr>
+          <a:xfrm>
+            <a:off x="548640" y="4389120"/>
+            <a:ext cx="5431536" cy="1325880"/>
+          </a:xfrm>
+          <a:prstGeom prst="roundRect">
+            <a:avLst/>
+          </a:prstGeom>
+          <a:solidFill>
+            <a:srgbClr val="E8EAF6"/>
+          </a:solidFill>
+          <a:ln w="15875">
+            <a:solidFill>
+              <a:srgbClr val="3949AB"/>
+            </a:solidFill>
+            <a:prstDash val="solid"/>
+          </a:ln>
+        </p:spPr>
+      </p:sp>
+      <p:sp>
+        <p:nvSpPr>
+          <p:cNvPr id="22" name="Shape 20"/>
+          <p:cNvSpPr/>
+          <p:nvPr/>
+        </p:nvSpPr>
+        <p:spPr>
+          <a:xfrm>
+            <a:off x="731520" y="4759452"/>
+            <a:ext cx="566928" cy="566928"/>
+          </a:xfrm>
+          <a:prstGeom prst="ellipse">
+            <a:avLst/>
+          </a:prstGeom>
+          <a:solidFill>
+            <a:srgbClr val="3949AB"/>
+          </a:solidFill>
+          <a:ln w="12700">
+            <a:solidFill>
+              <a:srgbClr val="3949AB"/>
+            </a:solidFill>
+            <a:prstDash val="solid"/>
+          </a:ln>
+        </p:spPr>
+      </p:sp>
+      <p:sp>
+        <p:nvSpPr>
+          <p:cNvPr id="23" name="Text 21"/>
+          <p:cNvSpPr/>
+          <p:nvPr/>
+        </p:nvSpPr>
+        <p:spPr>
+          <a:xfrm>
+            <a:off x="731520" y="4759452"/>
+            <a:ext cx="566928" cy="566928"/>
+          </a:xfrm>
+          <a:prstGeom prst="rect">
+            <a:avLst/>
+          </a:prstGeom>
+          <a:noFill/>
+          <a:ln/>
+        </p:spPr>
+        <p:txBody>
+          <a:bodyPr wrap="square" rtlCol="0" anchor="ctr"/>
+          <a:lstStyle/>
           <a:p>
-            <a:pPr marL="190500" indent="-190500">
-              <a:spcAft>
-                <a:spcPts val="1400"/>
-              </a:spcAft>
-              <a:buSzPct val="100000"/>
-              <a:buChar char="•"/>
+            <a:pPr algn="ctr" indent="0" marL="0">
+              <a:buNone/>
             </a:pPr>
             <a:r>
-              <a:rPr lang="en-US" sz="1600" dirty="0">
+              <a:rPr lang="en-US" sz="1700" b="1" dirty="0">
+                <a:solidFill>
+                  <a:srgbClr val="FFFFFF"/>
+                </a:solidFill>
+                <a:latin typeface="Arial" pitchFamily="34" charset="0"/>
+                <a:ea typeface="Arial" pitchFamily="34" charset="-122"/>
+                <a:cs typeface="Arial" pitchFamily="34" charset="-120"/>
+              </a:rPr>
+              <a:t>5</a:t>
+            </a:r>
+            <a:endParaRPr lang="en-US" sz="1700" dirty="0"/>
+          </a:p>
+        </p:txBody>
+      </p:sp>
+      <p:sp>
+        <p:nvSpPr>
+          <p:cNvPr id="24" name="Text 22"/>
+          <p:cNvSpPr/>
+          <p:nvPr/>
+        </p:nvSpPr>
+        <p:spPr>
+          <a:xfrm>
+            <a:off x="1417320" y="4389120"/>
+            <a:ext cx="4379976" cy="1325880"/>
+          </a:xfrm>
+          <a:prstGeom prst="rect">
+            <a:avLst/>
+          </a:prstGeom>
+          <a:noFill/>
+          <a:ln/>
+        </p:spPr>
+        <p:txBody>
+          <a:bodyPr wrap="square" rtlCol="0" anchor="ctr"/>
+          <a:lstStyle/>
+          <a:p>
+            <a:pPr indent="0" marL="0">
+              <a:buNone/>
+            </a:pPr>
+            <a:r>
+              <a:rPr lang="en-US" sz="1500" dirty="0">
                 <a:solidFill>
                   <a:srgbClr val="212121"/>
                 </a:solidFill>
@@ -8216,18 +8729,125 @@
               </a:rPr>
               <a:t>Apagar, ajustar tamaños y mover datos fríos son palancas más sencillas que cambiar de modelo; el etiquetado hace visible dónde aplicarlas.</a:t>
             </a:r>
-            <a:endParaRPr lang="en-US" sz="1600" dirty="0"/>
+            <a:endParaRPr lang="en-US" sz="1500" dirty="0"/>
           </a:p>
+        </p:txBody>
+      </p:sp>
+      <p:sp>
+        <p:nvSpPr>
+          <p:cNvPr id="25" name="Shape 23"/>
+          <p:cNvSpPr/>
+          <p:nvPr/>
+        </p:nvSpPr>
+        <p:spPr>
+          <a:xfrm>
+            <a:off x="6208776" y="4389120"/>
+            <a:ext cx="5431536" cy="1325880"/>
+          </a:xfrm>
+          <a:prstGeom prst="roundRect">
+            <a:avLst/>
+          </a:prstGeom>
+          <a:solidFill>
+            <a:srgbClr val="E8EAF6"/>
+          </a:solidFill>
+          <a:ln w="15875">
+            <a:solidFill>
+              <a:srgbClr val="3949AB"/>
+            </a:solidFill>
+            <a:prstDash val="solid"/>
+          </a:ln>
+        </p:spPr>
+      </p:sp>
+      <p:sp>
+        <p:nvSpPr>
+          <p:cNvPr id="26" name="Shape 24"/>
+          <p:cNvSpPr/>
+          <p:nvPr/>
+        </p:nvSpPr>
+        <p:spPr>
+          <a:xfrm>
+            <a:off x="6391656" y="4759452"/>
+            <a:ext cx="566928" cy="566928"/>
+          </a:xfrm>
+          <a:prstGeom prst="ellipse">
+            <a:avLst/>
+          </a:prstGeom>
+          <a:solidFill>
+            <a:srgbClr val="3949AB"/>
+          </a:solidFill>
+          <a:ln w="12700">
+            <a:solidFill>
+              <a:srgbClr val="3949AB"/>
+            </a:solidFill>
+            <a:prstDash val="solid"/>
+          </a:ln>
+        </p:spPr>
+      </p:sp>
+      <p:sp>
+        <p:nvSpPr>
+          <p:cNvPr id="27" name="Text 25"/>
+          <p:cNvSpPr/>
+          <p:nvPr/>
+        </p:nvSpPr>
+        <p:spPr>
+          <a:xfrm>
+            <a:off x="6391656" y="4759452"/>
+            <a:ext cx="566928" cy="566928"/>
+          </a:xfrm>
+          <a:prstGeom prst="rect">
+            <a:avLst/>
+          </a:prstGeom>
+          <a:noFill/>
+          <a:ln/>
+        </p:spPr>
+        <p:txBody>
+          <a:bodyPr wrap="square" rtlCol="0" anchor="ctr"/>
+          <a:lstStyle/>
           <a:p>
-            <a:pPr marL="190500" indent="-190500">
-              <a:spcAft>
-                <a:spcPts val="1400"/>
-              </a:spcAft>
-              <a:buSzPct val="100000"/>
-              <a:buChar char="•"/>
+            <a:pPr algn="ctr" indent="0" marL="0">
+              <a:buNone/>
             </a:pPr>
             <a:r>
-              <a:rPr lang="en-US" sz="1600" dirty="0">
+              <a:rPr lang="en-US" sz="1700" b="1" dirty="0">
+                <a:solidFill>
+                  <a:srgbClr val="FFFFFF"/>
+                </a:solidFill>
+                <a:latin typeface="Arial" pitchFamily="34" charset="0"/>
+                <a:ea typeface="Arial" pitchFamily="34" charset="-122"/>
+                <a:cs typeface="Arial" pitchFamily="34" charset="-120"/>
+              </a:rPr>
+              <a:t>6</a:t>
+            </a:r>
+            <a:endParaRPr lang="en-US" sz="1700" dirty="0"/>
+          </a:p>
+        </p:txBody>
+      </p:sp>
+      <p:sp>
+        <p:nvSpPr>
+          <p:cNvPr id="28" name="Text 26"/>
+          <p:cNvSpPr/>
+          <p:nvPr/>
+        </p:nvSpPr>
+        <p:spPr>
+          <a:xfrm>
+            <a:off x="7077456" y="4389120"/>
+            <a:ext cx="4379976" cy="1325880"/>
+          </a:xfrm>
+          <a:prstGeom prst="rect">
+            <a:avLst/>
+          </a:prstGeom>
+          <a:noFill/>
+          <a:ln/>
+        </p:spPr>
+        <p:txBody>
+          <a:bodyPr wrap="square" rtlCol="0" anchor="ctr"/>
+          <a:lstStyle/>
+          <a:p>
+            <a:pPr indent="0" marL="0">
+              <a:buNone/>
+            </a:pPr>
+            <a:r>
+              <a:rPr lang="en-US" sz="1500" dirty="0">
                 <a:solidFill>
                   <a:srgbClr val="212121"/>
                 </a:solidFill>
@@ -8237,7 +8857,7 @@
               </a:rPr>
               <a:t>La calculadora estima antes de construir; Cost Explorer y los presupuestos miden el gasto real después.</a:t>
             </a:r>
-            <a:endParaRPr lang="en-US" sz="1600" dirty="0"/>
+            <a:endParaRPr lang="en-US" sz="1500" dirty="0"/>
           </a:p>
         </p:txBody>
       </p:sp>

</xml_diff>